<commit_message>
Option B: show which entities reviewed each norm
Adds Interna/Externa/SSF visit chips to the NRP-20 highlight card and to
each repeated-norm card.

Co-Authored-By: Claude Opus 5.5 <noreply@anthropic.com>
Claude-Session: https://claude.ai/code/session_01QC1XfLyMdcgUULyFVZxtv6
</commit_message>
<xml_diff>
--- a/presentacion-lunes/Resumen_Riesgos_2026_Opcion_B.pptx
+++ b/presentacion-lunes/Resumen_Riesgos_2026_Opcion_B.pptx
@@ -5054,7 +5054,7 @@
         <p:spPr>
           <a:xfrm>
             <a:off x="9326880" y="2011680"/>
-            <a:ext cx="2331720" cy="1234440"/>
+            <a:ext cx="2331720" cy="1097280"/>
           </a:xfrm>
           <a:prstGeom prst="roundRect">
             <a:avLst>
@@ -5099,8 +5099,8 @@
         </p:nvSpPr>
         <p:spPr>
           <a:xfrm>
-            <a:off x="9555480" y="2148840"/>
-            <a:ext cx="1874519" cy="228600"/>
+            <a:off x="9555480" y="2121408"/>
+            <a:ext cx="1874519" cy="201168"/>
           </a:xfrm>
           <a:prstGeom prst="rect">
             <a:avLst/>
@@ -5134,8 +5134,8 @@
         </p:nvSpPr>
         <p:spPr>
           <a:xfrm>
-            <a:off x="9555480" y="2313432"/>
-            <a:ext cx="1874519" cy="502920"/>
+            <a:off x="9528048" y="2377440"/>
+            <a:ext cx="685800" cy="594360"/>
           </a:xfrm>
           <a:prstGeom prst="rect">
             <a:avLst/>
@@ -5169,8 +5169,8 @@
         </p:nvSpPr>
         <p:spPr>
           <a:xfrm>
-            <a:off x="9555480" y="2862072"/>
-            <a:ext cx="1874519" cy="201168"/>
+            <a:off x="10222992" y="2395728"/>
+            <a:ext cx="1344167" cy="548640"/>
           </a:xfrm>
           <a:prstGeom prst="rect">
             <a:avLst/>
@@ -5178,14 +5178,14 @@
           <a:noFill/>
         </p:spPr>
         <p:txBody>
-          <a:bodyPr wrap="square" lIns="0" rIns="0" tIns="0" bIns="0" anchor="t">
+          <a:bodyPr wrap="square" lIns="0" rIns="0" tIns="0" bIns="0" anchor="ctr">
             <a:spAutoFit/>
           </a:bodyPr>
           <a:lstStyle/>
           <a:p>
             <a:pPr algn="l"/>
             <a:r>
-              <a:rPr sz="1200" b="1">
+              <a:rPr sz="1000" b="1">
                 <a:solidFill>
                   <a:srgbClr val="FFFFFF"/>
                 </a:solidFill>
@@ -5194,53 +5194,30 @@
               <a:t>visitas y auditorías</a:t>
             </a:r>
           </a:p>
-        </p:txBody>
-      </p:sp>
-      <p:sp>
-        <p:nvSpPr>
-          <p:cNvPr id="37" name="TextBox 36"/>
-          <p:cNvSpPr txBox="1"/>
-          <p:nvPr/>
-        </p:nvSpPr>
-        <p:spPr>
-          <a:xfrm>
-            <a:off x="9555480" y="3044952"/>
-            <a:ext cx="1874519" cy="182880"/>
-          </a:xfrm>
-          <a:prstGeom prst="rect">
-            <a:avLst/>
-          </a:prstGeom>
-          <a:noFill/>
-        </p:spPr>
-        <p:txBody>
-          <a:bodyPr wrap="square" lIns="0" rIns="0" tIns="0" bIns="0" anchor="t">
-            <a:spAutoFit/>
-          </a:bodyPr>
-          <a:lstStyle/>
           <a:p>
             <a:pPr algn="l"/>
             <a:r>
-              <a:rPr sz="1000" b="0">
+              <a:rPr sz="900" b="0">
                 <a:solidFill>
                   <a:srgbClr val="9CC3E8"/>
                 </a:solidFill>
                 <a:latin typeface="Arial"/>
               </a:rPr>
-              <a:t>26 temas distintos pedidos</a:t>
-            </a:r>
-          </a:p>
-        </p:txBody>
-      </p:sp>
-      <p:sp>
-        <p:nvSpPr>
-          <p:cNvPr id="38" name="Norma más auditada"/>
+              <a:t>26 temas distintos</a:t>
+            </a:r>
+          </a:p>
+        </p:txBody>
+      </p:sp>
+      <p:sp>
+        <p:nvSpPr>
+          <p:cNvPr id="37" name="Norma más auditada"/>
           <p:cNvSpPr/>
           <p:nvPr/>
         </p:nvSpPr>
         <p:spPr>
           <a:xfrm>
-            <a:off x="9326880" y="3383280"/>
-            <a:ext cx="2331720" cy="868680"/>
+            <a:off x="9326880" y="3218688"/>
+            <a:ext cx="2331720" cy="1033272"/>
           </a:xfrm>
           <a:prstGeom prst="roundRect">
             <a:avLst>
@@ -5279,14 +5256,93 @@
       </p:sp>
       <p:sp>
         <p:nvSpPr>
+          <p:cNvPr id="38" name="TextBox 37"/>
+          <p:cNvSpPr txBox="1"/>
+          <p:nvPr/>
+        </p:nvSpPr>
+        <p:spPr>
+          <a:xfrm>
+            <a:off x="9528048" y="3310128"/>
+            <a:ext cx="1929384" cy="182880"/>
+          </a:xfrm>
+          <a:prstGeom prst="rect">
+            <a:avLst/>
+          </a:prstGeom>
+          <a:noFill/>
+        </p:spPr>
+        <p:txBody>
+          <a:bodyPr wrap="square" lIns="0" rIns="0" tIns="0" bIns="0" anchor="t">
+            <a:spAutoFit/>
+          </a:bodyPr>
+          <a:lstStyle/>
+          <a:p>
+            <a:pPr algn="l"/>
+            <a:r>
+              <a:rPr sz="1000" b="1">
+                <a:solidFill>
+                  <a:srgbClr val="5B6B7B"/>
+                </a:solidFill>
+                <a:latin typeface="Arial"/>
+              </a:rPr>
+              <a:t>NORMA MÁS AUDITADA</a:t>
+            </a:r>
+          </a:p>
+        </p:txBody>
+      </p:sp>
+      <p:sp>
+        <p:nvSpPr>
           <p:cNvPr id="39" name="TextBox 38"/>
           <p:cNvSpPr txBox="1"/>
           <p:nvPr/>
         </p:nvSpPr>
         <p:spPr>
           <a:xfrm>
-            <a:off x="9555480" y="3493008"/>
-            <a:ext cx="1874519" cy="201168"/>
+            <a:off x="9528048" y="3493008"/>
+            <a:ext cx="1929384" cy="329184"/>
+          </a:xfrm>
+          <a:prstGeom prst="rect">
+            <a:avLst/>
+          </a:prstGeom>
+          <a:noFill/>
+        </p:spPr>
+        <p:txBody>
+          <a:bodyPr wrap="square" lIns="0" rIns="0" tIns="0" bIns="0" anchor="ctr">
+            <a:spAutoFit/>
+          </a:bodyPr>
+          <a:lstStyle/>
+          <a:p>
+            <a:pPr algn="l"/>
+            <a:r>
+              <a:rPr sz="2200" b="1">
+                <a:solidFill>
+                  <a:srgbClr val="003D6F"/>
+                </a:solidFill>
+                <a:latin typeface="Century Gothic"/>
+              </a:rPr>
+              <a:t>NRP-20</a:t>
+            </a:r>
+            <a:r>
+              <a:rPr sz="1100" b="1">
+                <a:solidFill>
+                  <a:srgbClr val="C62828"/>
+                </a:solidFill>
+                <a:latin typeface="Arial"/>
+              </a:rPr>
+              <a:t>  5 veces</a:t>
+            </a:r>
+          </a:p>
+        </p:txBody>
+      </p:sp>
+      <p:sp>
+        <p:nvSpPr>
+          <p:cNvPr id="40" name="TextBox 39"/>
+          <p:cNvSpPr txBox="1"/>
+          <p:nvPr/>
+        </p:nvSpPr>
+        <p:spPr>
+          <a:xfrm>
+            <a:off x="9528048" y="3822192"/>
+            <a:ext cx="1929384" cy="164592"/>
           </a:xfrm>
           <a:prstGeom prst="rect">
             <a:avLst/>
@@ -5301,90 +5357,185 @@
           <a:p>
             <a:pPr algn="l"/>
             <a:r>
-              <a:rPr sz="1000" b="1">
+              <a:rPr sz="900" b="0">
                 <a:solidFill>
                   <a:srgbClr val="5B6B7B"/>
                 </a:solidFill>
                 <a:latin typeface="Arial"/>
               </a:rPr>
-              <a:t>NORMA MÁS AUDITADA</a:t>
-            </a:r>
-          </a:p>
-        </p:txBody>
-      </p:sp>
-      <p:sp>
-        <p:nvSpPr>
-          <p:cNvPr id="40" name="TextBox 39"/>
-          <p:cNvSpPr txBox="1"/>
+              <a:t>La revisaron:</a:t>
+            </a:r>
+          </a:p>
+        </p:txBody>
+      </p:sp>
+      <p:sp>
+        <p:nvSpPr>
+          <p:cNvPr id="41" name="Rounded Rectangle 40"/>
+          <p:cNvSpPr/>
           <p:nvPr/>
         </p:nvSpPr>
         <p:spPr>
           <a:xfrm>
-            <a:off x="9555480" y="3675888"/>
-            <a:ext cx="1874519" cy="365760"/>
-          </a:xfrm>
-          <a:prstGeom prst="rect">
-            <a:avLst/>
-          </a:prstGeom>
-          <a:noFill/>
-        </p:spPr>
-        <p:txBody>
-          <a:bodyPr wrap="square" lIns="0" rIns="0" tIns="0" bIns="0" anchor="ctr">
-            <a:spAutoFit/>
-          </a:bodyPr>
-          <a:lstStyle/>
-          <a:p>
-            <a:pPr algn="l"/>
-            <a:r>
-              <a:rPr sz="2400" b="1">
-                <a:solidFill>
-                  <a:srgbClr val="003D6F"/>
-                </a:solidFill>
-                <a:latin typeface="Century Gothic"/>
-              </a:rPr>
-              <a:t>NRP-20</a:t>
-            </a:r>
-          </a:p>
-        </p:txBody>
-      </p:sp>
-      <p:sp>
-        <p:nvSpPr>
-          <p:cNvPr id="41" name="TextBox 40"/>
-          <p:cNvSpPr txBox="1"/>
-          <p:nvPr/>
-        </p:nvSpPr>
-        <p:spPr>
-          <a:xfrm>
-            <a:off x="9555480" y="4041648"/>
-            <a:ext cx="1874519" cy="182880"/>
-          </a:xfrm>
-          <a:prstGeom prst="rect">
-            <a:avLst/>
-          </a:prstGeom>
-          <a:noFill/>
-        </p:spPr>
-        <p:txBody>
-          <a:bodyPr wrap="square" lIns="0" rIns="0" tIns="0" bIns="0" anchor="t">
-            <a:spAutoFit/>
-          </a:bodyPr>
-          <a:lstStyle/>
-          <a:p>
-            <a:pPr algn="l"/>
-            <a:r>
-              <a:rPr sz="1000" b="0">
-                <a:solidFill>
-                  <a:srgbClr val="5B6B7B"/>
+            <a:off x="9528048" y="3995928"/>
+            <a:ext cx="612648" cy="219456"/>
+          </a:xfrm>
+          <a:prstGeom prst="roundRect">
+            <a:avLst>
+              <a:gd name="adj" fmla="val 50000"/>
+            </a:avLst>
+          </a:prstGeom>
+          <a:solidFill>
+            <a:srgbClr val="1565C0"/>
+          </a:solidFill>
+          <a:ln>
+            <a:noFill/>
+          </a:ln>
+          <a:effectLst/>
+        </p:spPr>
+        <p:style>
+          <a:lnRef idx="1">
+            <a:schemeClr val="accent1"/>
+          </a:lnRef>
+          <a:fillRef idx="3">
+            <a:schemeClr val="accent1"/>
+          </a:fillRef>
+          <a:effectRef idx="2">
+            <a:schemeClr val="accent1"/>
+          </a:effectRef>
+          <a:fontRef idx="minor">
+            <a:schemeClr val="lt1"/>
+          </a:fontRef>
+        </p:style>
+        <p:txBody>
+          <a:bodyPr rtlCol="0" anchor="ctr" lIns="0" rIns="0" tIns="0" bIns="0"/>
+          <a:lstStyle/>
+          <a:p>
+            <a:pPr algn="ctr"/>
+            <a:r>
+              <a:rPr sz="800" b="1">
+                <a:solidFill>
+                  <a:srgbClr val="FFFFFF"/>
                 </a:solidFill>
                 <a:latin typeface="Arial"/>
               </a:rPr>
-              <a:t>5 veces · 3 entidades</a:t>
-            </a:r>
-          </a:p>
-        </p:txBody>
-      </p:sp>
-      <p:sp>
-        <p:nvSpPr>
-          <p:cNvPr id="42" name="Oval 41"/>
+              <a:t>Interna ×2</a:t>
+            </a:r>
+          </a:p>
+        </p:txBody>
+      </p:sp>
+      <p:sp>
+        <p:nvSpPr>
+          <p:cNvPr id="42" name="Rounded Rectangle 41"/>
+          <p:cNvSpPr/>
+          <p:nvPr/>
+        </p:nvSpPr>
+        <p:spPr>
+          <a:xfrm>
+            <a:off x="10186416" y="3995928"/>
+            <a:ext cx="612648" cy="219456"/>
+          </a:xfrm>
+          <a:prstGeom prst="roundRect">
+            <a:avLst>
+              <a:gd name="adj" fmla="val 50000"/>
+            </a:avLst>
+          </a:prstGeom>
+          <a:solidFill>
+            <a:srgbClr val="E8871E"/>
+          </a:solidFill>
+          <a:ln>
+            <a:noFill/>
+          </a:ln>
+          <a:effectLst/>
+        </p:spPr>
+        <p:style>
+          <a:lnRef idx="1">
+            <a:schemeClr val="accent1"/>
+          </a:lnRef>
+          <a:fillRef idx="3">
+            <a:schemeClr val="accent1"/>
+          </a:fillRef>
+          <a:effectRef idx="2">
+            <a:schemeClr val="accent1"/>
+          </a:effectRef>
+          <a:fontRef idx="minor">
+            <a:schemeClr val="lt1"/>
+          </a:fontRef>
+        </p:style>
+        <p:txBody>
+          <a:bodyPr rtlCol="0" anchor="ctr" lIns="0" rIns="0" tIns="0" bIns="0"/>
+          <a:lstStyle/>
+          <a:p>
+            <a:pPr algn="ctr"/>
+            <a:r>
+              <a:rPr sz="800" b="1">
+                <a:solidFill>
+                  <a:srgbClr val="FFFFFF"/>
+                </a:solidFill>
+                <a:latin typeface="Arial"/>
+              </a:rPr>
+              <a:t>Externa ×1</a:t>
+            </a:r>
+          </a:p>
+        </p:txBody>
+      </p:sp>
+      <p:sp>
+        <p:nvSpPr>
+          <p:cNvPr id="43" name="Rounded Rectangle 42"/>
+          <p:cNvSpPr/>
+          <p:nvPr/>
+        </p:nvSpPr>
+        <p:spPr>
+          <a:xfrm>
+            <a:off x="10844784" y="3995928"/>
+            <a:ext cx="411480" cy="219456"/>
+          </a:xfrm>
+          <a:prstGeom prst="roundRect">
+            <a:avLst>
+              <a:gd name="adj" fmla="val 50000"/>
+            </a:avLst>
+          </a:prstGeom>
+          <a:solidFill>
+            <a:srgbClr val="2E9E5B"/>
+          </a:solidFill>
+          <a:ln>
+            <a:noFill/>
+          </a:ln>
+          <a:effectLst/>
+        </p:spPr>
+        <p:style>
+          <a:lnRef idx="1">
+            <a:schemeClr val="accent1"/>
+          </a:lnRef>
+          <a:fillRef idx="3">
+            <a:schemeClr val="accent1"/>
+          </a:fillRef>
+          <a:effectRef idx="2">
+            <a:schemeClr val="accent1"/>
+          </a:effectRef>
+          <a:fontRef idx="minor">
+            <a:schemeClr val="lt1"/>
+          </a:fontRef>
+        </p:style>
+        <p:txBody>
+          <a:bodyPr rtlCol="0" anchor="ctr" lIns="0" rIns="0" tIns="0" bIns="0"/>
+          <a:lstStyle/>
+          <a:p>
+            <a:pPr algn="ctr"/>
+            <a:r>
+              <a:rPr sz="800" b="1">
+                <a:solidFill>
+                  <a:srgbClr val="FFFFFF"/>
+                </a:solidFill>
+                <a:latin typeface="Arial"/>
+              </a:rPr>
+              <a:t>SSF ×2</a:t>
+            </a:r>
+          </a:p>
+        </p:txBody>
+      </p:sp>
+      <p:sp>
+        <p:nvSpPr>
+          <p:cNvPr id="44" name="Oval 43"/>
           <p:cNvSpPr/>
           <p:nvPr/>
         </p:nvSpPr>
@@ -5428,7 +5579,7 @@
       </p:sp>
       <p:pic>
         <p:nvPicPr>
-          <p:cNvPr id="43" name="Picture 42" descr="FaSyncAlt_white.png"/>
+          <p:cNvPr id="45" name="Picture 44" descr="FaSyncAlt_white.png"/>
           <p:cNvPicPr>
             <a:picLocks noChangeAspect="1"/>
           </p:cNvPicPr>
@@ -5452,7 +5603,7 @@
       </p:pic>
       <p:sp>
         <p:nvSpPr>
-          <p:cNvPr id="44" name="TextBox 43"/>
+          <p:cNvPr id="46" name="TextBox 45"/>
           <p:cNvSpPr txBox="1"/>
           <p:nvPr/>
         </p:nvSpPr>
@@ -5496,7 +5647,7 @@
       </p:sp>
       <p:sp>
         <p:nvSpPr>
-          <p:cNvPr id="45" name="TextBox 44"/>
+          <p:cNvPr id="47" name="TextBox 46"/>
           <p:cNvSpPr txBox="1"/>
           <p:nvPr/>
         </p:nvSpPr>
@@ -5531,14 +5682,14 @@
       </p:sp>
       <p:sp>
         <p:nvSpPr>
-          <p:cNvPr id="46" name="Rounded Rectangle 45"/>
+          <p:cNvPr id="48" name="Rounded Rectangle 47"/>
           <p:cNvSpPr/>
           <p:nvPr/>
         </p:nvSpPr>
         <p:spPr>
           <a:xfrm>
             <a:off x="548640" y="4937760"/>
-            <a:ext cx="2112264" cy="1371600"/>
+            <a:ext cx="2112264" cy="1463040"/>
           </a:xfrm>
           <a:prstGeom prst="roundRect">
             <a:avLst>
@@ -5579,7 +5730,7 @@
       </p:sp>
       <p:sp>
         <p:nvSpPr>
-          <p:cNvPr id="47" name="TextBox 46"/>
+          <p:cNvPr id="49" name="TextBox 48"/>
           <p:cNvSpPr txBox="1"/>
           <p:nvPr/>
         </p:nvSpPr>
@@ -5614,7 +5765,7 @@
       </p:sp>
       <p:sp>
         <p:nvSpPr>
-          <p:cNvPr id="48" name="TextBox 47"/>
+          <p:cNvPr id="50" name="TextBox 49"/>
           <p:cNvSpPr txBox="1"/>
           <p:nvPr/>
         </p:nvSpPr>
@@ -5649,14 +5800,14 @@
       </p:sp>
       <p:sp>
         <p:nvSpPr>
-          <p:cNvPr id="49" name="TextBox 48"/>
+          <p:cNvPr id="51" name="TextBox 50"/>
           <p:cNvSpPr txBox="1"/>
           <p:nvPr/>
         </p:nvSpPr>
         <p:spPr>
           <a:xfrm>
-            <a:off x="713232" y="5614416"/>
-            <a:ext cx="1783080" cy="640080"/>
+            <a:off x="713232" y="5596128"/>
+            <a:ext cx="1783080" cy="457200"/>
           </a:xfrm>
           <a:prstGeom prst="rect">
             <a:avLst/>
@@ -5684,14 +5835,179 @@
       </p:sp>
       <p:sp>
         <p:nvSpPr>
-          <p:cNvPr id="50" name="Rounded Rectangle 49"/>
+          <p:cNvPr id="52" name="Rounded Rectangle 51"/>
           <p:cNvSpPr/>
           <p:nvPr/>
         </p:nvSpPr>
         <p:spPr>
           <a:xfrm>
+            <a:off x="713232" y="6080760"/>
+            <a:ext cx="612648" cy="219456"/>
+          </a:xfrm>
+          <a:prstGeom prst="roundRect">
+            <a:avLst>
+              <a:gd name="adj" fmla="val 50000"/>
+            </a:avLst>
+          </a:prstGeom>
+          <a:solidFill>
+            <a:srgbClr val="1565C0"/>
+          </a:solidFill>
+          <a:ln>
+            <a:noFill/>
+          </a:ln>
+          <a:effectLst/>
+        </p:spPr>
+        <p:style>
+          <a:lnRef idx="1">
+            <a:schemeClr val="accent1"/>
+          </a:lnRef>
+          <a:fillRef idx="3">
+            <a:schemeClr val="accent1"/>
+          </a:fillRef>
+          <a:effectRef idx="2">
+            <a:schemeClr val="accent1"/>
+          </a:effectRef>
+          <a:fontRef idx="minor">
+            <a:schemeClr val="lt1"/>
+          </a:fontRef>
+        </p:style>
+        <p:txBody>
+          <a:bodyPr rtlCol="0" anchor="ctr" lIns="0" rIns="0" tIns="0" bIns="0"/>
+          <a:lstStyle/>
+          <a:p>
+            <a:pPr algn="ctr"/>
+            <a:r>
+              <a:rPr sz="800" b="1">
+                <a:solidFill>
+                  <a:srgbClr val="FFFFFF"/>
+                </a:solidFill>
+                <a:latin typeface="Arial"/>
+              </a:rPr>
+              <a:t>Interna ×2</a:t>
+            </a:r>
+          </a:p>
+        </p:txBody>
+      </p:sp>
+      <p:sp>
+        <p:nvSpPr>
+          <p:cNvPr id="53" name="Rounded Rectangle 52"/>
+          <p:cNvSpPr/>
+          <p:nvPr/>
+        </p:nvSpPr>
+        <p:spPr>
+          <a:xfrm>
+            <a:off x="1371600" y="6080760"/>
+            <a:ext cx="612648" cy="219456"/>
+          </a:xfrm>
+          <a:prstGeom prst="roundRect">
+            <a:avLst>
+              <a:gd name="adj" fmla="val 50000"/>
+            </a:avLst>
+          </a:prstGeom>
+          <a:solidFill>
+            <a:srgbClr val="E8871E"/>
+          </a:solidFill>
+          <a:ln>
+            <a:noFill/>
+          </a:ln>
+          <a:effectLst/>
+        </p:spPr>
+        <p:style>
+          <a:lnRef idx="1">
+            <a:schemeClr val="accent1"/>
+          </a:lnRef>
+          <a:fillRef idx="3">
+            <a:schemeClr val="accent1"/>
+          </a:fillRef>
+          <a:effectRef idx="2">
+            <a:schemeClr val="accent1"/>
+          </a:effectRef>
+          <a:fontRef idx="minor">
+            <a:schemeClr val="lt1"/>
+          </a:fontRef>
+        </p:style>
+        <p:txBody>
+          <a:bodyPr rtlCol="0" anchor="ctr" lIns="0" rIns="0" tIns="0" bIns="0"/>
+          <a:lstStyle/>
+          <a:p>
+            <a:pPr algn="ctr"/>
+            <a:r>
+              <a:rPr sz="800" b="1">
+                <a:solidFill>
+                  <a:srgbClr val="FFFFFF"/>
+                </a:solidFill>
+                <a:latin typeface="Arial"/>
+              </a:rPr>
+              <a:t>Externa ×1</a:t>
+            </a:r>
+          </a:p>
+        </p:txBody>
+      </p:sp>
+      <p:sp>
+        <p:nvSpPr>
+          <p:cNvPr id="54" name="Rounded Rectangle 53"/>
+          <p:cNvSpPr/>
+          <p:nvPr/>
+        </p:nvSpPr>
+        <p:spPr>
+          <a:xfrm>
+            <a:off x="2029968" y="6080760"/>
+            <a:ext cx="411480" cy="219456"/>
+          </a:xfrm>
+          <a:prstGeom prst="roundRect">
+            <a:avLst>
+              <a:gd name="adj" fmla="val 50000"/>
+            </a:avLst>
+          </a:prstGeom>
+          <a:solidFill>
+            <a:srgbClr val="2E9E5B"/>
+          </a:solidFill>
+          <a:ln>
+            <a:noFill/>
+          </a:ln>
+          <a:effectLst/>
+        </p:spPr>
+        <p:style>
+          <a:lnRef idx="1">
+            <a:schemeClr val="accent1"/>
+          </a:lnRef>
+          <a:fillRef idx="3">
+            <a:schemeClr val="accent1"/>
+          </a:fillRef>
+          <a:effectRef idx="2">
+            <a:schemeClr val="accent1"/>
+          </a:effectRef>
+          <a:fontRef idx="minor">
+            <a:schemeClr val="lt1"/>
+          </a:fontRef>
+        </p:style>
+        <p:txBody>
+          <a:bodyPr rtlCol="0" anchor="ctr" lIns="0" rIns="0" tIns="0" bIns="0"/>
+          <a:lstStyle/>
+          <a:p>
+            <a:pPr algn="ctr"/>
+            <a:r>
+              <a:rPr sz="800" b="1">
+                <a:solidFill>
+                  <a:srgbClr val="FFFFFF"/>
+                </a:solidFill>
+                <a:latin typeface="Arial"/>
+              </a:rPr>
+              <a:t>SSF ×2</a:t>
+            </a:r>
+          </a:p>
+        </p:txBody>
+      </p:sp>
+      <p:sp>
+        <p:nvSpPr>
+          <p:cNvPr id="55" name="Rounded Rectangle 54"/>
+          <p:cNvSpPr/>
+          <p:nvPr/>
+        </p:nvSpPr>
+        <p:spPr>
+          <a:xfrm>
             <a:off x="2798064" y="4937760"/>
-            <a:ext cx="2112264" cy="1371600"/>
+            <a:ext cx="2112264" cy="1463040"/>
           </a:xfrm>
           <a:prstGeom prst="roundRect">
             <a:avLst>
@@ -5732,7 +6048,7 @@
       </p:sp>
       <p:sp>
         <p:nvSpPr>
-          <p:cNvPr id="51" name="TextBox 50"/>
+          <p:cNvPr id="56" name="TextBox 55"/>
           <p:cNvSpPr txBox="1"/>
           <p:nvPr/>
         </p:nvSpPr>
@@ -5767,7 +6083,7 @@
       </p:sp>
       <p:sp>
         <p:nvSpPr>
-          <p:cNvPr id="52" name="TextBox 51"/>
+          <p:cNvPr id="57" name="TextBox 56"/>
           <p:cNvSpPr txBox="1"/>
           <p:nvPr/>
         </p:nvSpPr>
@@ -5802,14 +6118,14 @@
       </p:sp>
       <p:sp>
         <p:nvSpPr>
-          <p:cNvPr id="53" name="TextBox 52"/>
+          <p:cNvPr id="58" name="TextBox 57"/>
           <p:cNvSpPr txBox="1"/>
           <p:nvPr/>
         </p:nvSpPr>
         <p:spPr>
           <a:xfrm>
-            <a:off x="2962656" y="5614416"/>
-            <a:ext cx="1783080" cy="640080"/>
+            <a:off x="2962656" y="5596128"/>
+            <a:ext cx="1783080" cy="457200"/>
           </a:xfrm>
           <a:prstGeom prst="rect">
             <a:avLst/>
@@ -5837,14 +6153,124 @@
       </p:sp>
       <p:sp>
         <p:nvSpPr>
-          <p:cNvPr id="54" name="Rounded Rectangle 53"/>
+          <p:cNvPr id="59" name="Rounded Rectangle 58"/>
           <p:cNvSpPr/>
           <p:nvPr/>
         </p:nvSpPr>
         <p:spPr>
           <a:xfrm>
+            <a:off x="2962656" y="6080760"/>
+            <a:ext cx="612648" cy="219456"/>
+          </a:xfrm>
+          <a:prstGeom prst="roundRect">
+            <a:avLst>
+              <a:gd name="adj" fmla="val 50000"/>
+            </a:avLst>
+          </a:prstGeom>
+          <a:solidFill>
+            <a:srgbClr val="1565C0"/>
+          </a:solidFill>
+          <a:ln>
+            <a:noFill/>
+          </a:ln>
+          <a:effectLst/>
+        </p:spPr>
+        <p:style>
+          <a:lnRef idx="1">
+            <a:schemeClr val="accent1"/>
+          </a:lnRef>
+          <a:fillRef idx="3">
+            <a:schemeClr val="accent1"/>
+          </a:fillRef>
+          <a:effectRef idx="2">
+            <a:schemeClr val="accent1"/>
+          </a:effectRef>
+          <a:fontRef idx="minor">
+            <a:schemeClr val="lt1"/>
+          </a:fontRef>
+        </p:style>
+        <p:txBody>
+          <a:bodyPr rtlCol="0" anchor="ctr" lIns="0" rIns="0" tIns="0" bIns="0"/>
+          <a:lstStyle/>
+          <a:p>
+            <a:pPr algn="ctr"/>
+            <a:r>
+              <a:rPr sz="800" b="1">
+                <a:solidFill>
+                  <a:srgbClr val="FFFFFF"/>
+                </a:solidFill>
+                <a:latin typeface="Arial"/>
+              </a:rPr>
+              <a:t>Interna ×2</a:t>
+            </a:r>
+          </a:p>
+        </p:txBody>
+      </p:sp>
+      <p:sp>
+        <p:nvSpPr>
+          <p:cNvPr id="60" name="Rounded Rectangle 59"/>
+          <p:cNvSpPr/>
+          <p:nvPr/>
+        </p:nvSpPr>
+        <p:spPr>
+          <a:xfrm>
+            <a:off x="3621024" y="6080760"/>
+            <a:ext cx="612648" cy="219456"/>
+          </a:xfrm>
+          <a:prstGeom prst="roundRect">
+            <a:avLst>
+              <a:gd name="adj" fmla="val 50000"/>
+            </a:avLst>
+          </a:prstGeom>
+          <a:solidFill>
+            <a:srgbClr val="E8871E"/>
+          </a:solidFill>
+          <a:ln>
+            <a:noFill/>
+          </a:ln>
+          <a:effectLst/>
+        </p:spPr>
+        <p:style>
+          <a:lnRef idx="1">
+            <a:schemeClr val="accent1"/>
+          </a:lnRef>
+          <a:fillRef idx="3">
+            <a:schemeClr val="accent1"/>
+          </a:fillRef>
+          <a:effectRef idx="2">
+            <a:schemeClr val="accent1"/>
+          </a:effectRef>
+          <a:fontRef idx="minor">
+            <a:schemeClr val="lt1"/>
+          </a:fontRef>
+        </p:style>
+        <p:txBody>
+          <a:bodyPr rtlCol="0" anchor="ctr" lIns="0" rIns="0" tIns="0" bIns="0"/>
+          <a:lstStyle/>
+          <a:p>
+            <a:pPr algn="ctr"/>
+            <a:r>
+              <a:rPr sz="800" b="1">
+                <a:solidFill>
+                  <a:srgbClr val="FFFFFF"/>
+                </a:solidFill>
+                <a:latin typeface="Arial"/>
+              </a:rPr>
+              <a:t>Externa ×1</a:t>
+            </a:r>
+          </a:p>
+        </p:txBody>
+      </p:sp>
+      <p:sp>
+        <p:nvSpPr>
+          <p:cNvPr id="61" name="Rounded Rectangle 60"/>
+          <p:cNvSpPr/>
+          <p:nvPr/>
+        </p:nvSpPr>
+        <p:spPr>
+          <a:xfrm>
             <a:off x="5047488" y="4937760"/>
-            <a:ext cx="2112264" cy="1371600"/>
+            <a:ext cx="2112264" cy="1463040"/>
           </a:xfrm>
           <a:prstGeom prst="roundRect">
             <a:avLst>
@@ -5885,7 +6311,7 @@
       </p:sp>
       <p:sp>
         <p:nvSpPr>
-          <p:cNvPr id="55" name="TextBox 54"/>
+          <p:cNvPr id="62" name="TextBox 61"/>
           <p:cNvSpPr txBox="1"/>
           <p:nvPr/>
         </p:nvSpPr>
@@ -5920,7 +6346,7 @@
       </p:sp>
       <p:sp>
         <p:nvSpPr>
-          <p:cNvPr id="56" name="TextBox 55"/>
+          <p:cNvPr id="63" name="TextBox 62"/>
           <p:cNvSpPr txBox="1"/>
           <p:nvPr/>
         </p:nvSpPr>
@@ -5955,14 +6381,14 @@
       </p:sp>
       <p:sp>
         <p:nvSpPr>
-          <p:cNvPr id="57" name="TextBox 56"/>
+          <p:cNvPr id="64" name="TextBox 63"/>
           <p:cNvSpPr txBox="1"/>
           <p:nvPr/>
         </p:nvSpPr>
         <p:spPr>
           <a:xfrm>
-            <a:off x="5212079" y="5614416"/>
-            <a:ext cx="1783080" cy="640080"/>
+            <a:off x="5212079" y="5596128"/>
+            <a:ext cx="1783080" cy="457200"/>
           </a:xfrm>
           <a:prstGeom prst="rect">
             <a:avLst/>
@@ -5990,14 +6416,124 @@
       </p:sp>
       <p:sp>
         <p:nvSpPr>
-          <p:cNvPr id="58" name="Rounded Rectangle 57"/>
+          <p:cNvPr id="65" name="Rounded Rectangle 64"/>
           <p:cNvSpPr/>
           <p:nvPr/>
         </p:nvSpPr>
         <p:spPr>
           <a:xfrm>
+            <a:off x="5212079" y="6080760"/>
+            <a:ext cx="612648" cy="219456"/>
+          </a:xfrm>
+          <a:prstGeom prst="roundRect">
+            <a:avLst>
+              <a:gd name="adj" fmla="val 50000"/>
+            </a:avLst>
+          </a:prstGeom>
+          <a:solidFill>
+            <a:srgbClr val="1565C0"/>
+          </a:solidFill>
+          <a:ln>
+            <a:noFill/>
+          </a:ln>
+          <a:effectLst/>
+        </p:spPr>
+        <p:style>
+          <a:lnRef idx="1">
+            <a:schemeClr val="accent1"/>
+          </a:lnRef>
+          <a:fillRef idx="3">
+            <a:schemeClr val="accent1"/>
+          </a:fillRef>
+          <a:effectRef idx="2">
+            <a:schemeClr val="accent1"/>
+          </a:effectRef>
+          <a:fontRef idx="minor">
+            <a:schemeClr val="lt1"/>
+          </a:fontRef>
+        </p:style>
+        <p:txBody>
+          <a:bodyPr rtlCol="0" anchor="ctr" lIns="0" rIns="0" tIns="0" bIns="0"/>
+          <a:lstStyle/>
+          <a:p>
+            <a:pPr algn="ctr"/>
+            <a:r>
+              <a:rPr sz="800" b="1">
+                <a:solidFill>
+                  <a:srgbClr val="FFFFFF"/>
+                </a:solidFill>
+                <a:latin typeface="Arial"/>
+              </a:rPr>
+              <a:t>Interna ×2</a:t>
+            </a:r>
+          </a:p>
+        </p:txBody>
+      </p:sp>
+      <p:sp>
+        <p:nvSpPr>
+          <p:cNvPr id="66" name="Rounded Rectangle 65"/>
+          <p:cNvSpPr/>
+          <p:nvPr/>
+        </p:nvSpPr>
+        <p:spPr>
+          <a:xfrm>
+            <a:off x="5870447" y="6080760"/>
+            <a:ext cx="612648" cy="219456"/>
+          </a:xfrm>
+          <a:prstGeom prst="roundRect">
+            <a:avLst>
+              <a:gd name="adj" fmla="val 50000"/>
+            </a:avLst>
+          </a:prstGeom>
+          <a:solidFill>
+            <a:srgbClr val="E8871E"/>
+          </a:solidFill>
+          <a:ln>
+            <a:noFill/>
+          </a:ln>
+          <a:effectLst/>
+        </p:spPr>
+        <p:style>
+          <a:lnRef idx="1">
+            <a:schemeClr val="accent1"/>
+          </a:lnRef>
+          <a:fillRef idx="3">
+            <a:schemeClr val="accent1"/>
+          </a:fillRef>
+          <a:effectRef idx="2">
+            <a:schemeClr val="accent1"/>
+          </a:effectRef>
+          <a:fontRef idx="minor">
+            <a:schemeClr val="lt1"/>
+          </a:fontRef>
+        </p:style>
+        <p:txBody>
+          <a:bodyPr rtlCol="0" anchor="ctr" lIns="0" rIns="0" tIns="0" bIns="0"/>
+          <a:lstStyle/>
+          <a:p>
+            <a:pPr algn="ctr"/>
+            <a:r>
+              <a:rPr sz="800" b="1">
+                <a:solidFill>
+                  <a:srgbClr val="FFFFFF"/>
+                </a:solidFill>
+                <a:latin typeface="Arial"/>
+              </a:rPr>
+              <a:t>Externa ×1</a:t>
+            </a:r>
+          </a:p>
+        </p:txBody>
+      </p:sp>
+      <p:sp>
+        <p:nvSpPr>
+          <p:cNvPr id="67" name="Rounded Rectangle 66"/>
+          <p:cNvSpPr/>
+          <p:nvPr/>
+        </p:nvSpPr>
+        <p:spPr>
+          <a:xfrm>
             <a:off x="7296912" y="4937760"/>
-            <a:ext cx="2112264" cy="1371600"/>
+            <a:ext cx="2112264" cy="1463040"/>
           </a:xfrm>
           <a:prstGeom prst="roundRect">
             <a:avLst>
@@ -6038,7 +6574,7 @@
       </p:sp>
       <p:sp>
         <p:nvSpPr>
-          <p:cNvPr id="59" name="TextBox 58"/>
+          <p:cNvPr id="68" name="TextBox 67"/>
           <p:cNvSpPr txBox="1"/>
           <p:nvPr/>
         </p:nvSpPr>
@@ -6073,7 +6609,7 @@
       </p:sp>
       <p:sp>
         <p:nvSpPr>
-          <p:cNvPr id="60" name="TextBox 59"/>
+          <p:cNvPr id="69" name="TextBox 68"/>
           <p:cNvSpPr txBox="1"/>
           <p:nvPr/>
         </p:nvSpPr>
@@ -6108,14 +6644,14 @@
       </p:sp>
       <p:sp>
         <p:nvSpPr>
-          <p:cNvPr id="61" name="TextBox 60"/>
+          <p:cNvPr id="70" name="TextBox 69"/>
           <p:cNvSpPr txBox="1"/>
           <p:nvPr/>
         </p:nvSpPr>
         <p:spPr>
           <a:xfrm>
-            <a:off x="7461504" y="5614416"/>
-            <a:ext cx="1783080" cy="640080"/>
+            <a:off x="7461504" y="5596128"/>
+            <a:ext cx="1783080" cy="457200"/>
           </a:xfrm>
           <a:prstGeom prst="rect">
             <a:avLst/>
@@ -6143,14 +6679,124 @@
       </p:sp>
       <p:sp>
         <p:nvSpPr>
-          <p:cNvPr id="62" name="Rounded Rectangle 61"/>
+          <p:cNvPr id="71" name="Rounded Rectangle 70"/>
           <p:cNvSpPr/>
           <p:nvPr/>
         </p:nvSpPr>
         <p:spPr>
           <a:xfrm>
+            <a:off x="7461504" y="6080760"/>
+            <a:ext cx="612648" cy="219456"/>
+          </a:xfrm>
+          <a:prstGeom prst="roundRect">
+            <a:avLst>
+              <a:gd name="adj" fmla="val 50000"/>
+            </a:avLst>
+          </a:prstGeom>
+          <a:solidFill>
+            <a:srgbClr val="1565C0"/>
+          </a:solidFill>
+          <a:ln>
+            <a:noFill/>
+          </a:ln>
+          <a:effectLst/>
+        </p:spPr>
+        <p:style>
+          <a:lnRef idx="1">
+            <a:schemeClr val="accent1"/>
+          </a:lnRef>
+          <a:fillRef idx="3">
+            <a:schemeClr val="accent1"/>
+          </a:fillRef>
+          <a:effectRef idx="2">
+            <a:schemeClr val="accent1"/>
+          </a:effectRef>
+          <a:fontRef idx="minor">
+            <a:schemeClr val="lt1"/>
+          </a:fontRef>
+        </p:style>
+        <p:txBody>
+          <a:bodyPr rtlCol="0" anchor="ctr" lIns="0" rIns="0" tIns="0" bIns="0"/>
+          <a:lstStyle/>
+          <a:p>
+            <a:pPr algn="ctr"/>
+            <a:r>
+              <a:rPr sz="800" b="1">
+                <a:solidFill>
+                  <a:srgbClr val="FFFFFF"/>
+                </a:solidFill>
+                <a:latin typeface="Arial"/>
+              </a:rPr>
+              <a:t>Interna ×1</a:t>
+            </a:r>
+          </a:p>
+        </p:txBody>
+      </p:sp>
+      <p:sp>
+        <p:nvSpPr>
+          <p:cNvPr id="72" name="Rounded Rectangle 71"/>
+          <p:cNvSpPr/>
+          <p:nvPr/>
+        </p:nvSpPr>
+        <p:spPr>
+          <a:xfrm>
+            <a:off x="8119872" y="6080760"/>
+            <a:ext cx="612648" cy="219456"/>
+          </a:xfrm>
+          <a:prstGeom prst="roundRect">
+            <a:avLst>
+              <a:gd name="adj" fmla="val 50000"/>
+            </a:avLst>
+          </a:prstGeom>
+          <a:solidFill>
+            <a:srgbClr val="E8871E"/>
+          </a:solidFill>
+          <a:ln>
+            <a:noFill/>
+          </a:ln>
+          <a:effectLst/>
+        </p:spPr>
+        <p:style>
+          <a:lnRef idx="1">
+            <a:schemeClr val="accent1"/>
+          </a:lnRef>
+          <a:fillRef idx="3">
+            <a:schemeClr val="accent1"/>
+          </a:fillRef>
+          <a:effectRef idx="2">
+            <a:schemeClr val="accent1"/>
+          </a:effectRef>
+          <a:fontRef idx="minor">
+            <a:schemeClr val="lt1"/>
+          </a:fontRef>
+        </p:style>
+        <p:txBody>
+          <a:bodyPr rtlCol="0" anchor="ctr" lIns="0" rIns="0" tIns="0" bIns="0"/>
+          <a:lstStyle/>
+          <a:p>
+            <a:pPr algn="ctr"/>
+            <a:r>
+              <a:rPr sz="800" b="1">
+                <a:solidFill>
+                  <a:srgbClr val="FFFFFF"/>
+                </a:solidFill>
+                <a:latin typeface="Arial"/>
+              </a:rPr>
+              <a:t>Externa ×1</a:t>
+            </a:r>
+          </a:p>
+        </p:txBody>
+      </p:sp>
+      <p:sp>
+        <p:nvSpPr>
+          <p:cNvPr id="73" name="Rounded Rectangle 72"/>
+          <p:cNvSpPr/>
+          <p:nvPr/>
+        </p:nvSpPr>
+        <p:spPr>
+          <a:xfrm>
             <a:off x="9546336" y="4937760"/>
-            <a:ext cx="2112264" cy="1371600"/>
+            <a:ext cx="2112264" cy="1463040"/>
           </a:xfrm>
           <a:prstGeom prst="roundRect">
             <a:avLst>
@@ -6191,7 +6837,7 @@
       </p:sp>
       <p:sp>
         <p:nvSpPr>
-          <p:cNvPr id="63" name="TextBox 62"/>
+          <p:cNvPr id="74" name="TextBox 73"/>
           <p:cNvSpPr txBox="1"/>
           <p:nvPr/>
         </p:nvSpPr>
@@ -6226,7 +6872,7 @@
       </p:sp>
       <p:sp>
         <p:nvSpPr>
-          <p:cNvPr id="64" name="TextBox 63"/>
+          <p:cNvPr id="75" name="TextBox 74"/>
           <p:cNvSpPr txBox="1"/>
           <p:nvPr/>
         </p:nvSpPr>
@@ -6261,14 +6907,14 @@
       </p:sp>
       <p:sp>
         <p:nvSpPr>
-          <p:cNvPr id="65" name="TextBox 64"/>
+          <p:cNvPr id="76" name="TextBox 75"/>
           <p:cNvSpPr txBox="1"/>
           <p:nvPr/>
         </p:nvSpPr>
         <p:spPr>
           <a:xfrm>
-            <a:off x="9710928" y="5614416"/>
-            <a:ext cx="1783080" cy="640080"/>
+            <a:off x="9710928" y="5596128"/>
+            <a:ext cx="1783080" cy="457200"/>
           </a:xfrm>
           <a:prstGeom prst="rect">
             <a:avLst/>
@@ -6296,7 +6942,117 @@
       </p:sp>
       <p:sp>
         <p:nvSpPr>
-          <p:cNvPr id="66" name="Fuente"/>
+          <p:cNvPr id="77" name="Rounded Rectangle 76"/>
+          <p:cNvSpPr/>
+          <p:nvPr/>
+        </p:nvSpPr>
+        <p:spPr>
+          <a:xfrm>
+            <a:off x="9710928" y="6080760"/>
+            <a:ext cx="612648" cy="219456"/>
+          </a:xfrm>
+          <a:prstGeom prst="roundRect">
+            <a:avLst>
+              <a:gd name="adj" fmla="val 50000"/>
+            </a:avLst>
+          </a:prstGeom>
+          <a:solidFill>
+            <a:srgbClr val="1565C0"/>
+          </a:solidFill>
+          <a:ln>
+            <a:noFill/>
+          </a:ln>
+          <a:effectLst/>
+        </p:spPr>
+        <p:style>
+          <a:lnRef idx="1">
+            <a:schemeClr val="accent1"/>
+          </a:lnRef>
+          <a:fillRef idx="3">
+            <a:schemeClr val="accent1"/>
+          </a:fillRef>
+          <a:effectRef idx="2">
+            <a:schemeClr val="accent1"/>
+          </a:effectRef>
+          <a:fontRef idx="minor">
+            <a:schemeClr val="lt1"/>
+          </a:fontRef>
+        </p:style>
+        <p:txBody>
+          <a:bodyPr rtlCol="0" anchor="ctr" lIns="0" rIns="0" tIns="0" bIns="0"/>
+          <a:lstStyle/>
+          <a:p>
+            <a:pPr algn="ctr"/>
+            <a:r>
+              <a:rPr sz="800" b="1">
+                <a:solidFill>
+                  <a:srgbClr val="FFFFFF"/>
+                </a:solidFill>
+                <a:latin typeface="Arial"/>
+              </a:rPr>
+              <a:t>Interna ×1</a:t>
+            </a:r>
+          </a:p>
+        </p:txBody>
+      </p:sp>
+      <p:sp>
+        <p:nvSpPr>
+          <p:cNvPr id="78" name="Rounded Rectangle 77"/>
+          <p:cNvSpPr/>
+          <p:nvPr/>
+        </p:nvSpPr>
+        <p:spPr>
+          <a:xfrm>
+            <a:off x="10369296" y="6080760"/>
+            <a:ext cx="411480" cy="219456"/>
+          </a:xfrm>
+          <a:prstGeom prst="roundRect">
+            <a:avLst>
+              <a:gd name="adj" fmla="val 50000"/>
+            </a:avLst>
+          </a:prstGeom>
+          <a:solidFill>
+            <a:srgbClr val="2E9E5B"/>
+          </a:solidFill>
+          <a:ln>
+            <a:noFill/>
+          </a:ln>
+          <a:effectLst/>
+        </p:spPr>
+        <p:style>
+          <a:lnRef idx="1">
+            <a:schemeClr val="accent1"/>
+          </a:lnRef>
+          <a:fillRef idx="3">
+            <a:schemeClr val="accent1"/>
+          </a:fillRef>
+          <a:effectRef idx="2">
+            <a:schemeClr val="accent1"/>
+          </a:effectRef>
+          <a:fontRef idx="minor">
+            <a:schemeClr val="lt1"/>
+          </a:fontRef>
+        </p:style>
+        <p:txBody>
+          <a:bodyPr rtlCol="0" anchor="ctr" lIns="0" rIns="0" tIns="0" bIns="0"/>
+          <a:lstStyle/>
+          <a:p>
+            <a:pPr algn="ctr"/>
+            <a:r>
+              <a:rPr sz="800" b="1">
+                <a:solidFill>
+                  <a:srgbClr val="FFFFFF"/>
+                </a:solidFill>
+                <a:latin typeface="Arial"/>
+              </a:rPr>
+              <a:t>SSF ×1</a:t>
+            </a:r>
+          </a:p>
+        </p:txBody>
+      </p:sp>
+      <p:sp>
+        <p:nvSpPr>
+          <p:cNvPr id="79" name="Fuente"/>
           <p:cNvSpPr txBox="1"/>
           <p:nvPr/>
         </p:nvSpPr>

</xml_diff>